<commit_message>
Rebuild pptx artifacts after the centring fix
Claude-Session: https://claude.ai/code/session_01W6B791pxC7uC9sNEMg62kz
</commit_message>
<xml_diff>
--- a/examples/agency-pipeline-demo/deck.pptx
+++ b/examples/agency-pipeline-demo/deck.pptx
@@ -7418,7 +7418,7 @@
         <p:spPr>
           <a:xfrm>
             <a:off x="0" y="3950208"/>
-            <a:ext cx="7450614" cy="518159"/>
+            <a:ext cx="5707380" cy="518159"/>
           </a:xfrm>
           <a:prstGeom prst="rect">
             <a:avLst/>
@@ -7844,7 +7844,7 @@
         <p:spPr>
           <a:xfrm>
             <a:off x="3585131" y="2593848"/>
-            <a:ext cx="5021739" cy="609600"/>
+            <a:ext cx="5021738" cy="609600"/>
           </a:xfrm>
           <a:prstGeom prst="rect">
             <a:avLst/>
@@ -7949,8 +7949,8 @@
         </p:nvSpPr>
         <p:spPr>
           <a:xfrm>
-            <a:off x="7356496" y="2593848"/>
-            <a:ext cx="4835504" cy="609600"/>
+            <a:off x="7701280" y="2593848"/>
+            <a:ext cx="4490720" cy="609600"/>
           </a:xfrm>
           <a:prstGeom prst="rect">
             <a:avLst/>
@@ -8267,8 +8267,8 @@
         </p:nvSpPr>
         <p:spPr>
           <a:xfrm>
-            <a:off x="7264907" y="4861560"/>
-            <a:ext cx="4927093" cy="609600"/>
+            <a:off x="7701280" y="4861560"/>
+            <a:ext cx="4490720" cy="609600"/>
           </a:xfrm>
           <a:prstGeom prst="rect">
             <a:avLst/>
@@ -9694,7 +9694,7 @@
         <p:spPr>
           <a:xfrm>
             <a:off x="113596" y="1831849"/>
-            <a:ext cx="4263529" cy="883919"/>
+            <a:ext cx="4263528" cy="883919"/>
           </a:xfrm>
           <a:prstGeom prst="rect">
             <a:avLst/>
@@ -9874,7 +9874,7 @@
         <p:spPr>
           <a:xfrm>
             <a:off x="3528964" y="2990088"/>
-            <a:ext cx="5134073" cy="1645920"/>
+            <a:ext cx="5134072" cy="1645920"/>
           </a:xfrm>
           <a:prstGeom prst="rect">
             <a:avLst/>
@@ -10086,7 +10086,7 @@
         <p:spPr>
           <a:xfrm>
             <a:off x="9085044" y="4910328"/>
-            <a:ext cx="1723192" cy="518159"/>
+            <a:ext cx="1723191" cy="518159"/>
           </a:xfrm>
           <a:prstGeom prst="rect">
             <a:avLst/>
@@ -11908,7 +11908,7 @@
         <p:spPr>
           <a:xfrm>
             <a:off x="4518512" y="1645920"/>
-            <a:ext cx="3154977" cy="762000"/>
+            <a:ext cx="3154976" cy="762000"/>
           </a:xfrm>
           <a:prstGeom prst="rect">
             <a:avLst/>
@@ -12093,7 +12093,7 @@
         <p:spPr>
           <a:xfrm>
             <a:off x="5140147" y="5583935"/>
-            <a:ext cx="1911707" cy="426720"/>
+            <a:ext cx="1911706" cy="426720"/>
           </a:xfrm>
           <a:prstGeom prst="rect">
             <a:avLst/>
@@ -13676,7 +13676,7 @@
         <p:spPr>
           <a:xfrm>
             <a:off x="6339331" y="2401823"/>
-            <a:ext cx="2945387" cy="936752"/>
+            <a:ext cx="2945386" cy="936752"/>
           </a:xfrm>
           <a:prstGeom prst="rect">
             <a:avLst/>
@@ -13787,7 +13787,7 @@
         <p:spPr>
           <a:xfrm>
             <a:off x="3632707" y="3612895"/>
-            <a:ext cx="2945387" cy="936752"/>
+            <a:ext cx="2945386" cy="936752"/>
           </a:xfrm>
           <a:prstGeom prst="rect">
             <a:avLst/>
@@ -13861,7 +13861,7 @@
         <p:spPr>
           <a:xfrm>
             <a:off x="9045955" y="3612895"/>
-            <a:ext cx="2945387" cy="936752"/>
+            <a:ext cx="2945386" cy="936752"/>
           </a:xfrm>
           <a:prstGeom prst="rect">
             <a:avLst/>
@@ -14041,7 +14041,7 @@
         <p:spPr>
           <a:xfrm>
             <a:off x="9045955" y="4823967"/>
-            <a:ext cx="2945387" cy="936752"/>
+            <a:ext cx="2945386" cy="936752"/>
           </a:xfrm>
           <a:prstGeom prst="rect">
             <a:avLst/>

</xml_diff>